<commit_message>
Cambios archivos Settings y Launch .json y documento de presentacion
</commit_message>
<xml_diff>
--- a/docs/Presentacion_Blackjack_Diseno.pptx
+++ b/docs/Presentacion_Blackjack_Diseno.pptx
@@ -128,6 +128,35 @@
     </p:ext>
   </p:extLst>
 </p:presentation>
+</file>
+
+<file path=ppt/changesInfos/changesInfo1.xml><?xml version="1.0" encoding="utf-8"?>
+<pc:chgInfo xmlns:a="http://schemas.openxmlformats.org/drawingml/2006/main" xmlns:r="http://schemas.openxmlformats.org/officeDocument/2006/relationships" xmlns:ac="http://schemas.microsoft.com/office/drawing/2013/main/command" xmlns:pc="http://schemas.microsoft.com/office/powerpoint/2013/main/command">
+  <pc:docChgLst>
+    <pc:chgData name="Esteban Verduzco Raggio" userId="2094cd06-0cb0-4cd1-966e-d19650ed34d2" providerId="ADAL" clId="{F413C675-38F1-493E-977A-78BBDE94487B}"/>
+    <pc:docChg chg="modSld">
+      <pc:chgData name="Esteban Verduzco Raggio" userId="2094cd06-0cb0-4cd1-966e-d19650ed34d2" providerId="ADAL" clId="{F413C675-38F1-493E-977A-78BBDE94487B}" dt="2026-10-06T14:27:29.540" v="23" actId="20577"/>
+      <pc:docMkLst>
+        <pc:docMk/>
+      </pc:docMkLst>
+      <pc:sldChg chg="modSp mod">
+        <pc:chgData name="Esteban Verduzco Raggio" userId="2094cd06-0cb0-4cd1-966e-d19650ed34d2" providerId="ADAL" clId="{F413C675-38F1-493E-977A-78BBDE94487B}" dt="2026-10-06T14:27:29.540" v="23" actId="20577"/>
+        <pc:sldMkLst>
+          <pc:docMk/>
+          <pc:sldMk cId="141299130" sldId="262"/>
+        </pc:sldMkLst>
+        <pc:spChg chg="mod">
+          <ac:chgData name="Esteban Verduzco Raggio" userId="2094cd06-0cb0-4cd1-966e-d19650ed34d2" providerId="ADAL" clId="{F413C675-38F1-493E-977A-78BBDE94487B}" dt="2026-10-06T14:27:29.540" v="23" actId="20577"/>
+          <ac:spMkLst>
+            <pc:docMk/>
+            <pc:sldMk cId="141299130" sldId="262"/>
+            <ac:spMk id="15" creationId="{FD1F2FFB-71A8-AF27-D140-E98C1194CD0C}"/>
+          </ac:spMkLst>
+        </pc:spChg>
+      </pc:sldChg>
+    </pc:docChg>
+  </pc:docChgLst>
+</pc:chgInfo>
 </file>
 
 <file path=ppt/slideLayouts/slideLayout1.xml><?xml version="1.0" encoding="utf-8"?>
@@ -20371,15 +20400,15 @@
           <a:lstStyle/>
           <a:p>
             <a:r>
-              <a:rPr lang="es-ES" sz="1200">
+              <a:rPr lang="es-ES" sz="1200" dirty="0">
                 <a:solidFill>
                   <a:srgbClr val="263B4A"/>
                 </a:solidFill>
                 <a:latin typeface="Aptos" panose="020B0004020202020204" pitchFamily="34" charset="0"/>
               </a:rPr>
-              <a:t>El croupier lo llena y lo baraja antes de repartir otra carta.</a:t>
-            </a:r>
-            <a:endParaRPr lang="en-US" sz="1200">
+              <a:t>El croupier lo llena y lo baraja antes de repartir cartas.</a:t>
+            </a:r>
+            <a:endParaRPr lang="en-US" sz="1200" dirty="0">
               <a:solidFill>
                 <a:srgbClr val="263B4A"/>
               </a:solidFill>

</xml_diff>

<commit_message>
La presentación refleja la abstracción Blackjack para versionamiento de 1 o varios jugadores
</commit_message>
<xml_diff>
--- a/docs/Presentacion_Blackjack_Diseno.pptx
+++ b/docs/Presentacion_Blackjack_Diseno.pptx
@@ -134,8 +134,8 @@
 <pc:chgInfo xmlns:a="http://schemas.openxmlformats.org/drawingml/2006/main" xmlns:r="http://schemas.openxmlformats.org/officeDocument/2006/relationships" xmlns:ac="http://schemas.microsoft.com/office/drawing/2013/main/command" xmlns:pc="http://schemas.microsoft.com/office/powerpoint/2013/main/command">
   <pc:docChgLst>
     <pc:chgData name="Esteban Verduzco Raggio" userId="2094cd06-0cb0-4cd1-966e-d19650ed34d2" providerId="ADAL" clId="{F413C675-38F1-493E-977A-78BBDE94487B}"/>
-    <pc:docChg chg="modSld">
-      <pc:chgData name="Esteban Verduzco Raggio" userId="2094cd06-0cb0-4cd1-966e-d19650ed34d2" providerId="ADAL" clId="{F413C675-38F1-493E-977A-78BBDE94487B}" dt="2026-10-06T14:27:29.540" v="23" actId="20577"/>
+    <pc:docChg chg="custSel modSld">
+      <pc:chgData name="Esteban Verduzco Raggio" userId="2094cd06-0cb0-4cd1-966e-d19650ed34d2" providerId="ADAL" clId="{F413C675-38F1-493E-977A-78BBDE94487B}" dt="2026-10-08T16:36:33.205" v="137" actId="20577"/>
       <pc:docMkLst>
         <pc:docMk/>
       </pc:docMkLst>
@@ -151,6 +151,59 @@
             <pc:docMk/>
             <pc:sldMk cId="141299130" sldId="262"/>
             <ac:spMk id="15" creationId="{FD1F2FFB-71A8-AF27-D140-E98C1194CD0C}"/>
+          </ac:spMkLst>
+        </pc:spChg>
+      </pc:sldChg>
+      <pc:sldChg chg="modSp mod">
+        <pc:chgData name="Esteban Verduzco Raggio" userId="2094cd06-0cb0-4cd1-966e-d19650ed34d2" providerId="ADAL" clId="{F413C675-38F1-493E-977A-78BBDE94487B}" dt="2026-10-08T15:59:01.485" v="106" actId="20577"/>
+        <pc:sldMkLst>
+          <pc:docMk/>
+          <pc:sldMk cId="4219183123" sldId="268"/>
+        </pc:sldMkLst>
+        <pc:spChg chg="mod">
+          <ac:chgData name="Esteban Verduzco Raggio" userId="2094cd06-0cb0-4cd1-966e-d19650ed34d2" providerId="ADAL" clId="{F413C675-38F1-493E-977A-78BBDE94487B}" dt="2026-10-08T15:59:01.485" v="106" actId="20577"/>
+          <ac:spMkLst>
+            <pc:docMk/>
+            <pc:sldMk cId="4219183123" sldId="268"/>
+            <ac:spMk id="11" creationId="{80A57A18-5B50-91CD-140B-795B23E122F8}"/>
+          </ac:spMkLst>
+        </pc:spChg>
+      </pc:sldChg>
+      <pc:sldChg chg="modSp mod">
+        <pc:chgData name="Esteban Verduzco Raggio" userId="2094cd06-0cb0-4cd1-966e-d19650ed34d2" providerId="ADAL" clId="{F413C675-38F1-493E-977A-78BBDE94487B}" dt="2026-10-08T15:44:30.599" v="98" actId="20577"/>
+        <pc:sldMkLst>
+          <pc:docMk/>
+          <pc:sldMk cId="346411595" sldId="269"/>
+        </pc:sldMkLst>
+        <pc:spChg chg="mod">
+          <ac:chgData name="Esteban Verduzco Raggio" userId="2094cd06-0cb0-4cd1-966e-d19650ed34d2" providerId="ADAL" clId="{F413C675-38F1-493E-977A-78BBDE94487B}" dt="2026-10-08T15:44:13.891" v="61" actId="20577"/>
+          <ac:spMkLst>
+            <pc:docMk/>
+            <pc:sldMk cId="346411595" sldId="269"/>
+            <ac:spMk id="17" creationId="{C9305CCB-9737-F982-DD0D-B6E92D52786D}"/>
+          </ac:spMkLst>
+        </pc:spChg>
+        <pc:spChg chg="mod">
+          <ac:chgData name="Esteban Verduzco Raggio" userId="2094cd06-0cb0-4cd1-966e-d19650ed34d2" providerId="ADAL" clId="{F413C675-38F1-493E-977A-78BBDE94487B}" dt="2026-10-08T15:44:30.599" v="98" actId="20577"/>
+          <ac:spMkLst>
+            <pc:docMk/>
+            <pc:sldMk cId="346411595" sldId="269"/>
+            <ac:spMk id="21" creationId="{599230AD-A9F6-F3CB-EF38-A6CD9867C2AE}"/>
+          </ac:spMkLst>
+        </pc:spChg>
+      </pc:sldChg>
+      <pc:sldChg chg="modSp mod">
+        <pc:chgData name="Esteban Verduzco Raggio" userId="2094cd06-0cb0-4cd1-966e-d19650ed34d2" providerId="ADAL" clId="{F413C675-38F1-493E-977A-78BBDE94487B}" dt="2026-10-08T16:36:33.205" v="137" actId="20577"/>
+        <pc:sldMkLst>
+          <pc:docMk/>
+          <pc:sldMk cId="3345720358" sldId="270"/>
+        </pc:sldMkLst>
+        <pc:spChg chg="mod">
+          <ac:chgData name="Esteban Verduzco Raggio" userId="2094cd06-0cb0-4cd1-966e-d19650ed34d2" providerId="ADAL" clId="{F413C675-38F1-493E-977A-78BBDE94487B}" dt="2026-10-08T16:36:33.205" v="137" actId="20577"/>
+          <ac:spMkLst>
+            <pc:docMk/>
+            <pc:sldMk cId="3345720358" sldId="270"/>
+            <ac:spMk id="9" creationId="{ADD822D1-B08A-40C6-23C4-5CAFE562688E}"/>
           </ac:spMkLst>
         </pc:spChg>
       </pc:sldChg>
@@ -308,7 +361,7 @@
           <a:p>
             <a:fld id="{5F778B32-AA84-49F7-9CD4-27FC31DE7CEF}" type="datetimeFigureOut">
               <a:rPr lang="en-US" smtClean="0"/>
-              <a:t>10/6/2026</a:t>
+              <a:t>10/8/2026</a:t>
             </a:fld>
             <a:endParaRPr lang="en-US"/>
           </a:p>
@@ -508,7 +561,7 @@
           <a:p>
             <a:fld id="{5F778B32-AA84-49F7-9CD4-27FC31DE7CEF}" type="datetimeFigureOut">
               <a:rPr lang="en-US" smtClean="0"/>
-              <a:t>10/6/2026</a:t>
+              <a:t>10/8/2026</a:t>
             </a:fld>
             <a:endParaRPr lang="en-US"/>
           </a:p>
@@ -718,7 +771,7 @@
           <a:p>
             <a:fld id="{5F778B32-AA84-49F7-9CD4-27FC31DE7CEF}" type="datetimeFigureOut">
               <a:rPr lang="en-US" smtClean="0"/>
-              <a:t>10/6/2026</a:t>
+              <a:t>10/8/2026</a:t>
             </a:fld>
             <a:endParaRPr lang="en-US"/>
           </a:p>
@@ -918,7 +971,7 @@
           <a:p>
             <a:fld id="{5F778B32-AA84-49F7-9CD4-27FC31DE7CEF}" type="datetimeFigureOut">
               <a:rPr lang="en-US" smtClean="0"/>
-              <a:t>10/6/2026</a:t>
+              <a:t>10/8/2026</a:t>
             </a:fld>
             <a:endParaRPr lang="en-US"/>
           </a:p>
@@ -1194,7 +1247,7 @@
           <a:p>
             <a:fld id="{5F778B32-AA84-49F7-9CD4-27FC31DE7CEF}" type="datetimeFigureOut">
               <a:rPr lang="en-US" smtClean="0"/>
-              <a:t>10/6/2026</a:t>
+              <a:t>10/8/2026</a:t>
             </a:fld>
             <a:endParaRPr lang="en-US"/>
           </a:p>
@@ -1462,7 +1515,7 @@
           <a:p>
             <a:fld id="{5F778B32-AA84-49F7-9CD4-27FC31DE7CEF}" type="datetimeFigureOut">
               <a:rPr lang="en-US" smtClean="0"/>
-              <a:t>10/6/2026</a:t>
+              <a:t>10/8/2026</a:t>
             </a:fld>
             <a:endParaRPr lang="en-US"/>
           </a:p>
@@ -1877,7 +1930,7 @@
           <a:p>
             <a:fld id="{5F778B32-AA84-49F7-9CD4-27FC31DE7CEF}" type="datetimeFigureOut">
               <a:rPr lang="en-US" smtClean="0"/>
-              <a:t>10/6/2026</a:t>
+              <a:t>10/8/2026</a:t>
             </a:fld>
             <a:endParaRPr lang="en-US"/>
           </a:p>
@@ -2019,7 +2072,7 @@
           <a:p>
             <a:fld id="{5F778B32-AA84-49F7-9CD4-27FC31DE7CEF}" type="datetimeFigureOut">
               <a:rPr lang="en-US" smtClean="0"/>
-              <a:t>10/6/2026</a:t>
+              <a:t>10/8/2026</a:t>
             </a:fld>
             <a:endParaRPr lang="en-US"/>
           </a:p>
@@ -2132,7 +2185,7 @@
           <a:p>
             <a:fld id="{5F778B32-AA84-49F7-9CD4-27FC31DE7CEF}" type="datetimeFigureOut">
               <a:rPr lang="en-US" smtClean="0"/>
-              <a:t>10/6/2026</a:t>
+              <a:t>10/8/2026</a:t>
             </a:fld>
             <a:endParaRPr lang="en-US"/>
           </a:p>
@@ -2445,7 +2498,7 @@
           <a:p>
             <a:fld id="{5F778B32-AA84-49F7-9CD4-27FC31DE7CEF}" type="datetimeFigureOut">
               <a:rPr lang="en-US" smtClean="0"/>
-              <a:t>10/6/2026</a:t>
+              <a:t>10/8/2026</a:t>
             </a:fld>
             <a:endParaRPr lang="en-US"/>
           </a:p>
@@ -2734,7 +2787,7 @@
           <a:p>
             <a:fld id="{5F778B32-AA84-49F7-9CD4-27FC31DE7CEF}" type="datetimeFigureOut">
               <a:rPr lang="en-US" smtClean="0"/>
-              <a:t>10/6/2026</a:t>
+              <a:t>10/8/2026</a:t>
             </a:fld>
             <a:endParaRPr lang="en-US"/>
           </a:p>
@@ -2977,7 +3030,7 @@
           <a:p>
             <a:fld id="{5F778B32-AA84-49F7-9CD4-27FC31DE7CEF}" type="datetimeFigureOut">
               <a:rPr lang="en-US" smtClean="0"/>
-              <a:t>10/6/2026</a:t>
+              <a:t>10/8/2026</a:t>
             </a:fld>
             <a:endParaRPr lang="en-US"/>
           </a:p>
@@ -3721,7 +3774,7 @@
                 </a:solidFill>
                 <a:latin typeface="Aptos" panose="020B0004020202020204" pitchFamily="34" charset="0"/>
               </a:rPr>
-              <a:t>Clases, responsabilidades y recorrido de una partida</a:t>
+              <a:t>Estructura, reglas y recorrido de una partida</a:t>
             </a:r>
             <a:endParaRPr lang="en-US" sz="2100">
               <a:solidFill>
@@ -3836,7 +3889,7 @@
                 </a:solidFill>
                 <a:latin typeface="Aptos" panose="020B0004020202020204" pitchFamily="34" charset="0"/>
               </a:rPr>
-              <a:t>Una baraja · Hasta seis jugadores</a:t>
+              <a:t>Dos modalidades · Hasta seis jugadores</a:t>
             </a:r>
             <a:endParaRPr lang="en-US" sz="1200" b="1">
               <a:solidFill>
@@ -7261,15 +7314,15 @@
           <a:lstStyle/>
           <a:p>
             <a:r>
-              <a:rPr lang="es-ES" sz="1400">
+              <a:rPr lang="es-ES" sz="1400" dirty="0">
                 <a:solidFill>
                   <a:srgbClr val="FFF9EE"/>
                 </a:solidFill>
                 <a:latin typeface="Aptos" panose="020B0004020202020204" pitchFamily="34" charset="0"/>
               </a:rPr>
-              <a:t>Ana: 18 puntos  |  apuesta $20</a:t>
-            </a:r>
-            <a:endParaRPr lang="en-US" sz="1400">
+              <a:t>Lucía: 18 puntos  |  apuesta $20</a:t>
+            </a:r>
+            <a:endParaRPr lang="en-US" sz="1400" dirty="0">
               <a:solidFill>
                 <a:srgbClr val="FFF9EE"/>
               </a:solidFill>
@@ -8515,7 +8568,7 @@
           <a:lstStyle/>
           <a:p>
             <a:r>
-              <a:rPr lang="es-ES" sz="1200">
+              <a:rPr lang="es-ES" sz="1200" dirty="0">
                 <a:solidFill>
                   <a:srgbClr val="263B4A"/>
                 </a:solidFill>
@@ -8523,7 +8576,7 @@
               </a:rPr>
               <a:t>Crear las 52 cartas y mezclarlas.</a:t>
             </a:r>
-            <a:endParaRPr lang="en-US" sz="1200">
+            <a:endParaRPr lang="en-US" sz="1200" dirty="0">
               <a:solidFill>
                 <a:srgbClr val="263B4A"/>
               </a:solidFill>
@@ -8737,13 +8790,139 @@
           <a:lstStyle/>
           <a:p>
             <a:r>
-              <a:rPr lang="en-US" sz="1200">
+              <a:rPr lang="en-US" sz="1200" dirty="0">
                 <a:solidFill>
                   <a:srgbClr val="263B4A"/>
                 </a:solidFill>
                 <a:latin typeface="Aptos" panose="020B0004020202020204" pitchFamily="34" charset="0"/>
               </a:rPr>
-              <a:t>El turno de corte rota entre activos.</a:t>
+              <a:t>Un solo </a:t>
+            </a:r>
+            <a:r>
+              <a:rPr lang="en-US" sz="1200" dirty="0" err="1">
+                <a:solidFill>
+                  <a:srgbClr val="263B4A"/>
+                </a:solidFill>
+                <a:latin typeface="Aptos" panose="020B0004020202020204" pitchFamily="34" charset="0"/>
+              </a:rPr>
+              <a:t>jugador</a:t>
+            </a:r>
+            <a:r>
+              <a:rPr lang="en-US" sz="1200" dirty="0">
+                <a:solidFill>
+                  <a:srgbClr val="263B4A"/>
+                </a:solidFill>
+                <a:latin typeface="Aptos" panose="020B0004020202020204" pitchFamily="34" charset="0"/>
+              </a:rPr>
+              <a:t> </a:t>
+            </a:r>
+            <a:r>
+              <a:rPr lang="en-US" sz="1200" dirty="0" err="1">
+                <a:solidFill>
+                  <a:srgbClr val="263B4A"/>
+                </a:solidFill>
+                <a:latin typeface="Aptos" panose="020B0004020202020204" pitchFamily="34" charset="0"/>
+              </a:rPr>
+              <a:t>siempre</a:t>
+            </a:r>
+            <a:r>
+              <a:rPr lang="en-US" sz="1200" dirty="0">
+                <a:solidFill>
+                  <a:srgbClr val="263B4A"/>
+                </a:solidFill>
+                <a:latin typeface="Aptos" panose="020B0004020202020204" pitchFamily="34" charset="0"/>
+              </a:rPr>
+              <a:t> </a:t>
+            </a:r>
+            <a:r>
+              <a:rPr lang="en-US" sz="1200" dirty="0" err="1">
+                <a:solidFill>
+                  <a:srgbClr val="263B4A"/>
+                </a:solidFill>
+                <a:latin typeface="Aptos" panose="020B0004020202020204" pitchFamily="34" charset="0"/>
+              </a:rPr>
+              <a:t>corta</a:t>
+            </a:r>
+            <a:r>
+              <a:rPr lang="en-US" sz="1200" dirty="0">
+                <a:solidFill>
+                  <a:srgbClr val="263B4A"/>
+                </a:solidFill>
+                <a:latin typeface="Aptos" panose="020B0004020202020204" pitchFamily="34" charset="0"/>
+              </a:rPr>
+              <a:t>; </a:t>
+            </a:r>
+            <a:r>
+              <a:rPr lang="en-US" sz="1200" dirty="0" err="1">
+                <a:solidFill>
+                  <a:srgbClr val="263B4A"/>
+                </a:solidFill>
+                <a:latin typeface="Aptos" panose="020B0004020202020204" pitchFamily="34" charset="0"/>
+              </a:rPr>
+              <a:t>en</a:t>
+            </a:r>
+            <a:r>
+              <a:rPr lang="en-US" sz="1200" dirty="0">
+                <a:solidFill>
+                  <a:srgbClr val="263B4A"/>
+                </a:solidFill>
+                <a:latin typeface="Aptos" panose="020B0004020202020204" pitchFamily="34" charset="0"/>
+              </a:rPr>
+              <a:t> </a:t>
+            </a:r>
+            <a:r>
+              <a:rPr lang="en-US" sz="1200" dirty="0" err="1">
+                <a:solidFill>
+                  <a:srgbClr val="263B4A"/>
+                </a:solidFill>
+                <a:latin typeface="Aptos" panose="020B0004020202020204" pitchFamily="34" charset="0"/>
+              </a:rPr>
+              <a:t>multijugador</a:t>
+            </a:r>
+            <a:r>
+              <a:rPr lang="en-US" sz="1200" dirty="0">
+                <a:solidFill>
+                  <a:srgbClr val="263B4A"/>
+                </a:solidFill>
+                <a:latin typeface="Aptos" panose="020B0004020202020204" pitchFamily="34" charset="0"/>
+              </a:rPr>
+              <a:t> </a:t>
+            </a:r>
+            <a:r>
+              <a:rPr lang="en-US" sz="1200" dirty="0" err="1">
+                <a:solidFill>
+                  <a:srgbClr val="263B4A"/>
+                </a:solidFill>
+                <a:latin typeface="Aptos" panose="020B0004020202020204" pitchFamily="34" charset="0"/>
+              </a:rPr>
+              <a:t>rota</a:t>
+            </a:r>
+            <a:r>
+              <a:rPr lang="en-US" sz="1200" dirty="0">
+                <a:solidFill>
+                  <a:srgbClr val="263B4A"/>
+                </a:solidFill>
+                <a:latin typeface="Aptos" panose="020B0004020202020204" pitchFamily="34" charset="0"/>
+              </a:rPr>
+              <a:t> entre </a:t>
+            </a:r>
+            <a:r>
+              <a:rPr lang="en-US" sz="1200" dirty="0" err="1">
+                <a:solidFill>
+                  <a:srgbClr val="263B4A"/>
+                </a:solidFill>
+                <a:latin typeface="Aptos" panose="020B0004020202020204" pitchFamily="34" charset="0"/>
+              </a:rPr>
+              <a:t>activos</a:t>
+            </a:r>
+            <a:r>
+              <a:rPr lang="en-US" sz="1200" dirty="0">
+                <a:solidFill>
+                  <a:srgbClr val="263B4A"/>
+                </a:solidFill>
+                <a:latin typeface="Aptos" panose="020B0004020202020204" pitchFamily="34" charset="0"/>
+              </a:rPr>
+              <a:t>.</a:t>
             </a:r>
           </a:p>
         </p:txBody>
@@ -8953,15 +9132,15 @@
           <a:lstStyle/>
           <a:p>
             <a:r>
-              <a:rPr lang="es-ES" sz="1200">
+              <a:rPr lang="es-ES" sz="1200" dirty="0">
                 <a:solidFill>
                   <a:srgbClr val="263B4A"/>
                 </a:solidFill>
                 <a:latin typeface="Aptos" panose="020B0004020202020204" pitchFamily="34" charset="0"/>
               </a:rPr>
-              <a:t>Importe dentro del saldo y sobre el mínimo.</a:t>
-            </a:r>
-            <a:endParaRPr lang="en-US" sz="1200">
+              <a:t>Importe dentro del saldo y sobre el mínimo que el jugador pone a riesgo.</a:t>
+            </a:r>
+            <a:endParaRPr lang="en-US" sz="1200" dirty="0">
               <a:solidFill>
                 <a:srgbClr val="263B4A"/>
               </a:solidFill>
@@ -9006,7 +9185,7 @@
                 </a:solidFill>
                 <a:latin typeface="Aptos" panose="020B0004020202020204" pitchFamily="34" charset="0"/>
               </a:rPr>
-              <a:t>El flujo usa la lista de jugadores que continúan activos.</a:t>
+              <a:t>La base prepara la ronda; cada versión aporta su cortador y el recorrido de sus jugadores.</a:t>
             </a:r>
             <a:endParaRPr lang="en-US" sz="1200">
               <a:solidFill>
@@ -9198,7 +9377,7 @@
                 </a:solidFill>
                 <a:latin typeface="Aptos" panose="020B0004020202020204" pitchFamily="34" charset="0"/>
               </a:rPr>
-              <a:t>Dos cartas para cada jugador y dos para el croupier</a:t>
+              <a:t>Reparto inicial, con variante para cada modalidad</a:t>
             </a:r>
             <a:endParaRPr lang="en-US" sz="2500" b="1">
               <a:solidFill>
@@ -9455,13 +9634,121 @@
           <a:lstStyle/>
           <a:p>
             <a:r>
-              <a:rPr lang="en-US" sz="1600">
+              <a:rPr lang="en-US" sz="1600" dirty="0">
                 <a:solidFill>
                   <a:srgbClr val="263B4A"/>
                 </a:solidFill>
                 <a:latin typeface="Aptos" panose="020B0004020202020204" pitchFamily="34" charset="0"/>
               </a:rPr>
-              <a:t>Dos cartas por participante activo.</a:t>
+              <a:t>Dos cartas al </a:t>
+            </a:r>
+            <a:r>
+              <a:rPr lang="en-US" sz="1600" dirty="0" err="1">
+                <a:solidFill>
+                  <a:srgbClr val="263B4A"/>
+                </a:solidFill>
+                <a:latin typeface="Aptos" panose="020B0004020202020204" pitchFamily="34" charset="0"/>
+              </a:rPr>
+              <a:t>jugador</a:t>
+            </a:r>
+            <a:r>
+              <a:rPr lang="en-US" sz="1600" dirty="0">
+                <a:solidFill>
+                  <a:srgbClr val="263B4A"/>
+                </a:solidFill>
+                <a:latin typeface="Aptos" panose="020B0004020202020204" pitchFamily="34" charset="0"/>
+              </a:rPr>
+              <a:t> (o a </a:t>
+            </a:r>
+            <a:r>
+              <a:rPr lang="en-US" sz="1600" dirty="0" err="1">
+                <a:solidFill>
+                  <a:srgbClr val="263B4A"/>
+                </a:solidFill>
+                <a:latin typeface="Aptos" panose="020B0004020202020204" pitchFamily="34" charset="0"/>
+              </a:rPr>
+              <a:t>cada</a:t>
+            </a:r>
+            <a:r>
+              <a:rPr lang="en-US" sz="1600" dirty="0">
+                <a:solidFill>
+                  <a:srgbClr val="263B4A"/>
+                </a:solidFill>
+                <a:latin typeface="Aptos" panose="020B0004020202020204" pitchFamily="34" charset="0"/>
+              </a:rPr>
+              <a:t> </a:t>
+            </a:r>
+            <a:r>
+              <a:rPr lang="en-US" sz="1600" dirty="0" err="1">
+                <a:solidFill>
+                  <a:srgbClr val="263B4A"/>
+                </a:solidFill>
+                <a:latin typeface="Aptos" panose="020B0004020202020204" pitchFamily="34" charset="0"/>
+              </a:rPr>
+              <a:t>jugador</a:t>
+            </a:r>
+            <a:r>
+              <a:rPr lang="en-US" sz="1600" dirty="0">
+                <a:solidFill>
+                  <a:srgbClr val="263B4A"/>
+                </a:solidFill>
+                <a:latin typeface="Aptos" panose="020B0004020202020204" pitchFamily="34" charset="0"/>
+              </a:rPr>
+              <a:t> </a:t>
+            </a:r>
+            <a:r>
+              <a:rPr lang="en-US" sz="1600" dirty="0" err="1">
+                <a:solidFill>
+                  <a:srgbClr val="263B4A"/>
+                </a:solidFill>
+                <a:latin typeface="Aptos" panose="020B0004020202020204" pitchFamily="34" charset="0"/>
+              </a:rPr>
+              <a:t>activo</a:t>
+            </a:r>
+            <a:r>
+              <a:rPr lang="en-US" sz="1600" dirty="0">
+                <a:solidFill>
+                  <a:srgbClr val="263B4A"/>
+                </a:solidFill>
+                <a:latin typeface="Aptos" panose="020B0004020202020204" pitchFamily="34" charset="0"/>
+              </a:rPr>
+              <a:t> </a:t>
+            </a:r>
+            <a:r>
+              <a:rPr lang="en-US" sz="1600" dirty="0" err="1">
+                <a:solidFill>
+                  <a:srgbClr val="263B4A"/>
+                </a:solidFill>
+                <a:latin typeface="Aptos" panose="020B0004020202020204" pitchFamily="34" charset="0"/>
+              </a:rPr>
+              <a:t>en</a:t>
+            </a:r>
+            <a:r>
+              <a:rPr lang="en-US" sz="1600" dirty="0">
+                <a:solidFill>
+                  <a:srgbClr val="263B4A"/>
+                </a:solidFill>
+                <a:latin typeface="Aptos" panose="020B0004020202020204" pitchFamily="34" charset="0"/>
+              </a:rPr>
+              <a:t> </a:t>
+            </a:r>
+            <a:r>
+              <a:rPr lang="en-US" sz="1600" dirty="0" err="1">
+                <a:solidFill>
+                  <a:srgbClr val="263B4A"/>
+                </a:solidFill>
+                <a:latin typeface="Aptos" panose="020B0004020202020204" pitchFamily="34" charset="0"/>
+              </a:rPr>
+              <a:t>multijugador</a:t>
+            </a:r>
+            <a:r>
+              <a:rPr lang="en-US" sz="1600" dirty="0">
+                <a:solidFill>
+                  <a:srgbClr val="263B4A"/>
+                </a:solidFill>
+                <a:latin typeface="Aptos" panose="020B0004020202020204" pitchFamily="34" charset="0"/>
+              </a:rPr>
+              <a:t>).</a:t>
             </a:r>
           </a:p>
         </p:txBody>
@@ -10002,7 +10289,7 @@
                 </a:solidFill>
                 <a:latin typeface="Aptos" panose="020B0004020202020204" pitchFamily="34" charset="0"/>
               </a:rPr>
-              <a:t>Con Blackjack natural del croupier, se omiten los turnos de los jugadores.</a:t>
+              <a:t>El croupier ofrece un método para un jugador y otro para la lista multijugador.</a:t>
             </a:r>
             <a:endParaRPr lang="en-US" sz="1300">
               <a:solidFill>
@@ -14273,7 +14560,7 @@
                 </a:solidFill>
                 <a:latin typeface="Aptos" panose="020B0004020202020204" pitchFamily="34" charset="0"/>
               </a:rPr>
-              <a:t>Punto de entrada y arranque.</a:t>
+              <a:t>Elige la versión individual o multijugador.</a:t>
             </a:r>
             <a:endParaRPr lang="en-US" sz="1300">
               <a:solidFill>
@@ -14495,7 +14782,7 @@
                 </a:solidFill>
                 <a:latin typeface="Aptos" panose="020B0004020202020204" pitchFamily="34" charset="0"/>
               </a:rPr>
-              <a:t>Entrada validada y presentación de la mesa.</a:t>
+              <a:t>Pide datos, valida entradas y presenta la mesa.</a:t>
             </a:r>
             <a:endParaRPr lang="en-US" sz="1200">
               <a:solidFill>
@@ -14939,7 +15226,7 @@
                 </a:solidFill>
                 <a:latin typeface="Aptos" panose="020B0004020202020204" pitchFamily="34" charset="0"/>
               </a:rPr>
-              <a:t>Jugador y Croupier mantienen una mano.</a:t>
+              <a:t>Jugador y Croupier comparten nombre y mano.</a:t>
             </a:r>
             <a:endParaRPr lang="en-US" sz="1200">
               <a:solidFill>
@@ -15095,7 +15382,7 @@
                 </a:solidFill>
                 <a:latin typeface="Aptos" panose="020B0004020202020204" pitchFamily="34" charset="0"/>
               </a:rPr>
-              <a:t>coordina las etapas de la ronda</a:t>
+              <a:t>base común para las dos modalidades</a:t>
             </a:r>
             <a:endParaRPr lang="en-US" sz="1200">
               <a:solidFill>
@@ -15142,7 +15429,7 @@
                 </a:solidFill>
                 <a:latin typeface="Aptos" panose="020B0004020202020204" pitchFamily="34" charset="0"/>
               </a:rPr>
-              <a:t>El controlador conecta estos componentes y ordena las etapas del juego.</a:t>
+              <a:t>BlackjackUnJugador administra uno; BlackjackMultijugador administra una lista.</a:t>
             </a:r>
             <a:endParaRPr lang="en-US" sz="1200">
               <a:solidFill>
@@ -15334,7 +15621,7 @@
                 </a:solidFill>
                 <a:latin typeface="Aptos" panose="020B0004020202020204" pitchFamily="34" charset="0"/>
               </a:rPr>
-              <a:t>Inicio de la aplicación en tres pasos</a:t>
+              <a:t>Arranque: se elige modalidad y ciclo común</a:t>
             </a:r>
             <a:endParaRPr lang="en-US" sz="2500" b="1">
               <a:solidFill>
@@ -15597,33 +15884,9 @@
                 </a:solidFill>
                 <a:latin typeface="Aptos" panose="020B0004020202020204" pitchFamily="34" charset="0"/>
               </a:rPr>
-              <a:t>Configura la salida de texto y crea la consola.</a:t>
-            </a:r>
-          </a:p>
-          <a:p>
-            <a:endParaRPr lang="es-ES" sz="1500">
-              <a:solidFill>
-                <a:srgbClr val="263B4A"/>
-              </a:solidFill>
-              <a:latin typeface="Aptos" panose="020B0004020202020204" pitchFamily="34" charset="0"/>
-            </a:endParaRPr>
-          </a:p>
-          <a:p>
-            <a:r>
-              <a:rPr lang="es-ES" sz="1500">
-                <a:solidFill>
-                  <a:srgbClr val="263B4A"/>
-                </a:solidFill>
-                <a:latin typeface="Aptos" panose="020B0004020202020204" pitchFamily="34" charset="0"/>
-              </a:rPr>
-              <a:t>Solicita la cantidad de jugadores e inicia la partida.</a:t>
-            </a:r>
-            <a:endParaRPr lang="en-US" sz="1500">
-              <a:solidFill>
-                <a:srgbClr val="263B4A"/>
-              </a:solidFill>
-              <a:latin typeface="Aptos" panose="020B0004020202020204" pitchFamily="34" charset="0"/>
-            </a:endParaRPr>
+              <a:t>Configura UTF-8 y crea la consola.
+Lee cuántos jugarán y elige la modalidad.</a:t>
+            </a:r>
           </a:p>
         </p:txBody>
       </p:sp>
@@ -15838,33 +16101,9 @@
                 </a:solidFill>
                 <a:latin typeface="Aptos" panose="020B0004020202020204" pitchFamily="34" charset="0"/>
               </a:rPr>
-              <a:t>Registra a los jugadores.</a:t>
-            </a:r>
-          </a:p>
-          <a:p>
-            <a:endParaRPr lang="es-ES" sz="1500">
-              <a:solidFill>
-                <a:srgbClr val="263B4A"/>
-              </a:solidFill>
-              <a:latin typeface="Aptos" panose="020B0004020202020204" pitchFamily="34" charset="0"/>
-            </a:endParaRPr>
-          </a:p>
-          <a:p>
-            <a:r>
-              <a:rPr lang="es-ES" sz="1500">
-                <a:solidFill>
-                  <a:srgbClr val="263B4A"/>
-                </a:solidFill>
-                <a:latin typeface="Aptos" panose="020B0004020202020204" pitchFamily="34" charset="0"/>
-              </a:rPr>
-              <a:t>Comprueba si queda alguien activo y repite las rondas hasta que la mesa quede vacía.</a:t>
-            </a:r>
-            <a:endParaRPr lang="en-US" sz="1500">
-              <a:solidFill>
-                <a:srgbClr val="263B4A"/>
-              </a:solidFill>
-              <a:latin typeface="Aptos" panose="020B0004020202020204" pitchFamily="34" charset="0"/>
-            </a:endParaRPr>
+              <a:t>Registra jugadores y repite rondas mientras haya alguien activo.
+Mantiene fijo el orden general.</a:t>
+            </a:r>
           </a:p>
         </p:txBody>
       </p:sp>
@@ -16079,7 +16318,8 @@
                 </a:solidFill>
                 <a:latin typeface="Aptos" panose="020B0004020202020204" pitchFamily="34" charset="0"/>
               </a:rPr>
-              <a:t>Implementa las reglas: apuestas, reparto, turnos, comparación de manos y cierre de ronda.</a:t>
+              <a:t>La base abstracta comparte apuestas, reparto, turnos y resultados.
+Las subclases completan cada modalidad.</a:t>
             </a:r>
             <a:endParaRPr lang="en-US" sz="1400">
               <a:solidFill>
@@ -16126,7 +16366,7 @@
                 </a:solidFill>
                 <a:latin typeface="Aptos" panose="020B0004020202020204" pitchFamily="34" charset="0"/>
               </a:rPr>
-              <a:t>El constructor de Blackjack también solicita la apuesta mínima de la mesa.</a:t>
+              <a:t>Al construir el juego se fija la apuesta mínima y la estrategia del croupier.</a:t>
             </a:r>
             <a:endParaRPr lang="en-US" sz="1200">
               <a:solidFill>
@@ -17553,7 +17793,7 @@
                 </a:solidFill>
                 <a:latin typeface="Aptos" panose="020B0004020202020204" pitchFamily="34" charset="0"/>
               </a:rPr>
-              <a:t>Blackjack coordina cada ronda</a:t>
+              <a:t>Blackjack reutiliza reglas entre modalidades</a:t>
             </a:r>
           </a:p>
         </p:txBody>
@@ -18644,7 +18884,7 @@
                 </a:solidFill>
                 <a:latin typeface="Aptos" panose="020B0004020202020204" pitchFamily="34" charset="0"/>
               </a:rPr>
-              <a:t>El método de ronda llama estas etapas en orden y delega apuestas, turnos y liquidación.</a:t>
+              <a:t>La base Blackjack comparte estas etapas; las subclases registran jugadores y controlan su recorrido.</a:t>
             </a:r>
             <a:endParaRPr lang="en-US" sz="1500">
               <a:solidFill>
@@ -22473,7 +22713,7 @@
                 </a:solidFill>
                 <a:latin typeface="Aptos" panose="020B0004020202020204" pitchFamily="34" charset="0"/>
               </a:rPr>
-              <a:t>Croupier también tiene una mano; además administra el mazo y liquida resultados.</a:t>
+              <a:t>Croupier también hereda de Participante; Blackjack coordina sus reglas comunes para ambas versiones.</a:t>
             </a:r>
             <a:endParaRPr lang="en-US" sz="1200">
               <a:solidFill>

</xml_diff>